<commit_message>
update uftp test installation
</commit_message>
<xml_diff>
--- a/source/_static/test-uftp-setup.pptx
+++ b/source/_static/test-uftp-setup.pptx
@@ -3535,7 +3535,7 @@
         </p:nvSpPr>
         <p:spPr>
           <a:xfrm>
-            <a:off x="457200" y="182880"/>
+            <a:off x="872835" y="182880"/>
             <a:ext cx="4249305" cy="400110"/>
           </a:xfrm>
           <a:prstGeom prst="rect">
@@ -3572,7 +3572,7 @@
         </p:nvSpPr>
         <p:spPr>
           <a:xfrm>
-            <a:off x="916812" y="864690"/>
+            <a:off x="1018422" y="864690"/>
             <a:ext cx="1369188" cy="411480"/>
           </a:xfrm>
           <a:prstGeom prst="roundRect">
@@ -3623,7 +3623,7 @@
         </p:nvSpPr>
         <p:spPr>
           <a:xfrm>
-            <a:off x="5032097" y="1801824"/>
+            <a:off x="5133707" y="1857240"/>
             <a:ext cx="1645920" cy="411480"/>
           </a:xfrm>
           <a:prstGeom prst="roundRect">
@@ -3674,7 +3674,7 @@
         </p:nvSpPr>
         <p:spPr>
           <a:xfrm>
-            <a:off x="9418320" y="864690"/>
+            <a:off x="9519930" y="864690"/>
             <a:ext cx="1645920" cy="411480"/>
           </a:xfrm>
           <a:prstGeom prst="roundRect">
@@ -3725,8 +3725,8 @@
         </p:nvSpPr>
         <p:spPr>
           <a:xfrm>
-            <a:off x="817989" y="2389097"/>
-            <a:ext cx="1562965" cy="875241"/>
+            <a:off x="975016" y="2389097"/>
+            <a:ext cx="1455538" cy="875241"/>
           </a:xfrm>
           <a:prstGeom prst="roundRect">
             <a:avLst/>
@@ -3735,6 +3735,7 @@
             <a:schemeClr val="accent1">
               <a:lumMod val="60000"/>
               <a:lumOff val="40000"/>
+              <a:alpha val="30000"/>
             </a:schemeClr>
           </a:solidFill>
           <a:ln>
@@ -3771,7 +3772,7 @@
             </a:endParaRPr>
           </a:p>
           <a:p>
-            <a:pPr algn="ctr">
+            <a:pPr>
               <a:defRPr sz="1400"/>
             </a:pPr>
             <a:r>
@@ -3784,7 +3785,7 @@
             </a:r>
           </a:p>
           <a:p>
-            <a:pPr algn="ctr">
+            <a:pPr>
               <a:defRPr sz="1400"/>
             </a:pPr>
             <a:r>
@@ -3806,8 +3807,8 @@
         </p:nvSpPr>
         <p:spPr>
           <a:xfrm>
-            <a:off x="4174006" y="3433605"/>
-            <a:ext cx="2838587" cy="1261115"/>
+            <a:off x="4765966" y="3562909"/>
+            <a:ext cx="2355726" cy="867127"/>
           </a:xfrm>
           <a:prstGeom prst="roundRect">
             <a:avLst/>
@@ -3816,6 +3817,7 @@
             <a:schemeClr val="accent3">
               <a:lumMod val="60000"/>
               <a:lumOff val="40000"/>
+              <a:alpha val="31000"/>
             </a:schemeClr>
           </a:solidFill>
           <a:ln>
@@ -3846,19 +3848,26 @@
               <a:defRPr sz="1400"/>
             </a:pPr>
             <a:br>
-              <a:rPr lang="en-GB" dirty="0">
+              <a:rPr lang="en-GB" sz="1200" dirty="0">
                 <a:solidFill>
                   <a:srgbClr val="002060"/>
                 </a:solidFill>
               </a:rPr>
             </a:br>
-            <a:r>
+            <a:br>
               <a:rPr lang="en-GB" sz="1200" dirty="0">
                 <a:solidFill>
                   <a:srgbClr val="002060"/>
                 </a:solidFill>
               </a:rPr>
-              <a:t>• auth.p12 (server certificate)</a:t>
+            </a:br>
+            <a:r>
+              <a:rPr lang="en-GB" sz="1200" dirty="0">
+                <a:solidFill>
+                  <a:srgbClr val="002060"/>
+                </a:solidFill>
+              </a:rPr>
+              <a:t>• auth.p12</a:t>
             </a:r>
           </a:p>
           <a:p>
@@ -3887,66 +3896,18 @@
                   <a:srgbClr val="002060"/>
                 </a:solidFill>
               </a:rPr>
-              <a:t> (self-signed CA certificate)</a:t>
+              <a:t> </a:t>
             </a:r>
           </a:p>
           <a:p>
             <a:pPr>
               <a:defRPr sz="1400"/>
             </a:pPr>
-            <a:r>
-              <a:rPr lang="en-GB" sz="1200" dirty="0">
-                <a:solidFill>
-                  <a:srgbClr val="002060"/>
-                </a:solidFill>
-              </a:rPr>
-              <a:t>• user-authfile.txt (</a:t>
-            </a:r>
-            <a:r>
-              <a:rPr lang="en-GB" sz="1200" dirty="0" err="1">
-                <a:solidFill>
-                  <a:srgbClr val="002060"/>
-                </a:solidFill>
-              </a:rPr>
-              <a:t>username:password</a:t>
-            </a:r>
-            <a:r>
-              <a:rPr lang="en-GB" sz="1200" dirty="0">
-                <a:solidFill>
-                  <a:srgbClr val="002060"/>
-                </a:solidFill>
-              </a:rPr>
-              <a:t>)</a:t>
-            </a:r>
-          </a:p>
-          <a:p>
-            <a:pPr>
-              <a:defRPr sz="1400"/>
-            </a:pPr>
-            <a:r>
-              <a:rPr lang="en-GB" sz="1200" dirty="0">
-                <a:solidFill>
-                  <a:srgbClr val="002060"/>
-                </a:solidFill>
-              </a:rPr>
-              <a:t>• user-</a:t>
-            </a:r>
-            <a:r>
-              <a:rPr lang="en-GB" sz="1200" dirty="0" err="1">
-                <a:solidFill>
-                  <a:srgbClr val="002060"/>
-                </a:solidFill>
-              </a:rPr>
-              <a:t>mapfile.json</a:t>
-            </a:r>
-            <a:r>
-              <a:rPr lang="en-GB" sz="1200" dirty="0">
-                <a:solidFill>
-                  <a:srgbClr val="002060"/>
-                </a:solidFill>
-              </a:rPr>
-              <a:t> (user mapping)</a:t>
-            </a:r>
+            <a:endParaRPr lang="en-GB" sz="1200" dirty="0">
+              <a:solidFill>
+                <a:srgbClr val="002060"/>
+              </a:solidFill>
+            </a:endParaRPr>
           </a:p>
         </p:txBody>
       </p:sp>
@@ -3958,8 +3919,8 @@
         </p:nvSpPr>
         <p:spPr>
           <a:xfrm>
-            <a:off x="8846502" y="2828368"/>
-            <a:ext cx="2409632" cy="897186"/>
+            <a:off x="9624663" y="2754480"/>
+            <a:ext cx="1407776" cy="897186"/>
           </a:xfrm>
           <a:prstGeom prst="roundRect">
             <a:avLst/>
@@ -3968,6 +3929,7 @@
             <a:schemeClr val="accent4">
               <a:lumMod val="60000"/>
               <a:lumOff val="40000"/>
+              <a:alpha val="30000"/>
             </a:schemeClr>
           </a:solidFill>
           <a:ln>
@@ -4029,15 +3991,33 @@
                   <a:srgbClr val="002060"/>
                 </a:solidFill>
               </a:rPr>
-              <a:t> (</a:t>
-            </a:r>
-            <a:r>
-              <a:rPr lang="de-DE" sz="1200" dirty="0" err="1">
+              <a:t> </a:t>
+            </a:r>
+            <a:endParaRPr sz="1200" dirty="0">
+              <a:solidFill>
+                <a:srgbClr val="002060"/>
+              </a:solidFill>
+            </a:endParaRPr>
+          </a:p>
+          <a:p>
+            <a:pPr>
+              <a:defRPr sz="1400"/>
+            </a:pPr>
+            <a:r>
+              <a:rPr sz="1200" dirty="0">
                 <a:solidFill>
                   <a:srgbClr val="002060"/>
                 </a:solidFill>
               </a:rPr>
-              <a:t>server</a:t>
+              <a:t>• </a:t>
+            </a:r>
+            <a:r>
+              <a:rPr sz="1200" dirty="0" err="1">
+                <a:solidFill>
+                  <a:srgbClr val="002060"/>
+                </a:solidFill>
+              </a:rPr>
+              <a:t>cacert.pem</a:t>
             </a:r>
             <a:r>
               <a:rPr lang="de-DE" sz="1200" dirty="0">
@@ -4047,94 +4027,12 @@
               </a:rPr>
               <a:t> </a:t>
             </a:r>
-            <a:r>
-              <a:rPr lang="de-DE" sz="1200" dirty="0" err="1">
-                <a:solidFill>
-                  <a:srgbClr val="002060"/>
-                </a:solidFill>
-              </a:rPr>
-              <a:t>certificate</a:t>
-            </a:r>
-            <a:r>
-              <a:rPr lang="de-DE" sz="1200" dirty="0">
-                <a:solidFill>
-                  <a:srgbClr val="002060"/>
-                </a:solidFill>
-              </a:rPr>
-              <a:t>)</a:t>
-            </a:r>
             <a:endParaRPr sz="1200" dirty="0">
               <a:solidFill>
                 <a:srgbClr val="002060"/>
               </a:solidFill>
             </a:endParaRPr>
           </a:p>
-          <a:p>
-            <a:pPr>
-              <a:defRPr sz="1400"/>
-            </a:pPr>
-            <a:r>
-              <a:rPr sz="1200" dirty="0">
-                <a:solidFill>
-                  <a:srgbClr val="002060"/>
-                </a:solidFill>
-              </a:rPr>
-              <a:t>• </a:t>
-            </a:r>
-            <a:r>
-              <a:rPr sz="1200" dirty="0" err="1">
-                <a:solidFill>
-                  <a:srgbClr val="002060"/>
-                </a:solidFill>
-              </a:rPr>
-              <a:t>cacert.pem</a:t>
-            </a:r>
-            <a:r>
-              <a:rPr lang="de-DE" sz="1200" dirty="0">
-                <a:solidFill>
-                  <a:srgbClr val="002060"/>
-                </a:solidFill>
-              </a:rPr>
-              <a:t> (</a:t>
-            </a:r>
-            <a:r>
-              <a:rPr lang="de-DE" sz="1200" dirty="0" err="1">
-                <a:solidFill>
-                  <a:srgbClr val="002060"/>
-                </a:solidFill>
-              </a:rPr>
-              <a:t>self-signed</a:t>
-            </a:r>
-            <a:r>
-              <a:rPr lang="de-DE" sz="1200" dirty="0">
-                <a:solidFill>
-                  <a:srgbClr val="002060"/>
-                </a:solidFill>
-              </a:rPr>
-              <a:t> CA </a:t>
-            </a:r>
-            <a:r>
-              <a:rPr lang="de-DE" sz="1200" dirty="0" err="1">
-                <a:solidFill>
-                  <a:srgbClr val="002060"/>
-                </a:solidFill>
-              </a:rPr>
-              <a:t>cert</a:t>
-            </a:r>
-            <a:r>
-              <a:rPr lang="de-DE" sz="1200" dirty="0">
-                <a:solidFill>
-                  <a:srgbClr val="002060"/>
-                </a:solidFill>
-              </a:rPr>
-              <a:t>)</a:t>
-            </a:r>
-            <a:endParaRPr sz="1200" dirty="0">
-              <a:solidFill>
-                <a:srgbClr val="002060"/>
-              </a:solidFill>
-            </a:endParaRPr>
-          </a:p>
         </p:txBody>
       </p:sp>
       <p:cxnSp>
@@ -4142,13 +4040,12 @@
           <p:cNvPr id="9" name="Connector 8"/>
           <p:cNvCxnSpPr>
             <a:cxnSpLocks/>
-            <a:endCxn id="182" idx="1"/>
           </p:cNvCxnSpPr>
           <p:nvPr/>
         </p:nvCxnSpPr>
         <p:spPr>
           <a:xfrm>
-            <a:off x="2143518" y="1872954"/>
+            <a:off x="2309780" y="1872954"/>
             <a:ext cx="3116934" cy="949450"/>
           </a:xfrm>
           <a:prstGeom prst="line">
@@ -4187,8 +4084,8 @@
         </p:nvCxnSpPr>
         <p:spPr>
           <a:xfrm flipV="1">
-            <a:off x="6351447" y="2159207"/>
-            <a:ext cx="3373731" cy="649966"/>
+            <a:off x="6351461" y="2145395"/>
+            <a:ext cx="3400762" cy="700722"/>
           </a:xfrm>
           <a:prstGeom prst="line">
             <a:avLst/>
@@ -4227,14 +4124,14 @@
           <p:nvPr>
             <p:extLst>
               <p:ext uri="{D42A27DB-BD31-4B8C-83A1-F6EECF244321}">
-                <p14:modId xmlns:p14="http://schemas.microsoft.com/office/powerpoint/2010/main" val="1538361138"/>
+                <p14:modId xmlns:p14="http://schemas.microsoft.com/office/powerpoint/2010/main" val="2513190851"/>
               </p:ext>
             </p:extLst>
           </p:nvPr>
         </p:nvGraphicFramePr>
         <p:xfrm>
-          <a:off x="1520560" y="4968922"/>
-          <a:ext cx="8986117" cy="1706880"/>
+          <a:off x="916812" y="4816536"/>
+          <a:ext cx="10329585" cy="1706880"/>
         </p:xfrm>
         <a:graphic>
           <a:graphicData uri="http://schemas.openxmlformats.org/drawingml/2006/table">
@@ -4243,28 +4140,28 @@
                 <a:tableStyleId>{5C22544A-7EE6-4342-B048-85BDC9FD1C3A}</a:tableStyleId>
               </a:tblPr>
               <a:tblGrid>
-                <a:gridCol w="1486721">
+                <a:gridCol w="1546636">
                   <a:extLst>
                     <a:ext uri="{9D8B030D-6E8A-4147-A177-3AD203B41FA5}">
                       <a16:colId xmlns:a16="http://schemas.microsoft.com/office/drawing/2014/main" val="20000"/>
                     </a:ext>
                   </a:extLst>
                 </a:gridCol>
-                <a:gridCol w="1032812">
+                <a:gridCol w="1287821">
                   <a:extLst>
                     <a:ext uri="{9D8B030D-6E8A-4147-A177-3AD203B41FA5}">
                       <a16:colId xmlns:a16="http://schemas.microsoft.com/office/drawing/2014/main" val="20001"/>
                     </a:ext>
                   </a:extLst>
                 </a:gridCol>
-                <a:gridCol w="3090035">
+                <a:gridCol w="3070958">
                   <a:extLst>
                     <a:ext uri="{9D8B030D-6E8A-4147-A177-3AD203B41FA5}">
                       <a16:colId xmlns:a16="http://schemas.microsoft.com/office/drawing/2014/main" val="20002"/>
                     </a:ext>
                   </a:extLst>
                 </a:gridCol>
-                <a:gridCol w="3376549">
+                <a:gridCol w="4424170">
                   <a:extLst>
                     <a:ext uri="{9D8B030D-6E8A-4147-A177-3AD203B41FA5}">
                       <a16:colId xmlns:a16="http://schemas.microsoft.com/office/drawing/2014/main" val="20003"/>
@@ -4605,7 +4502,7 @@
                             <a:schemeClr val="tx1"/>
                           </a:solidFill>
                         </a:rPr>
-                        <a:t>Certificate of the Auth Server</a:t>
+                        <a:t>Auth Server certificate</a:t>
                       </a:r>
                     </a:p>
                   </a:txBody>
@@ -4662,8 +4559,17 @@
                             <a:schemeClr val="tx1"/>
                           </a:solidFill>
                         </a:rPr>
-                        <a:t>PKCS#12 file with Auth cert und private key</a:t>
+                        <a:t>PKCS#12 file </a:t>
                       </a:r>
+                      <a:r>
+                        <a:rPr lang="en-GB" sz="1200" dirty="0"/>
+                        <a:t>containing the Auth Server certificate and private key</a:t>
+                      </a:r>
+                      <a:endParaRPr lang="en-US" sz="1200" noProof="0" dirty="0">
+                        <a:solidFill>
+                          <a:schemeClr val="tx1"/>
+                        </a:solidFill>
+                      </a:endParaRPr>
                     </a:p>
                   </a:txBody>
                   <a:tcPr>
@@ -4910,7 +4816,7 @@
                             <a:schemeClr val="tx1"/>
                           </a:solidFill>
                         </a:rPr>
-                        <a:t>Self-signed</a:t>
+                        <a:t>Self-signed CA cert</a:t>
                       </a:r>
                     </a:p>
                   </a:txBody>
@@ -4974,7 +4880,7 @@
                             <a:schemeClr val="tx1"/>
                           </a:solidFill>
                         </a:rPr>
-                        <a:t>     user-authfile.txt</a:t>
+                        <a:t>      user-authfile.txt</a:t>
                       </a:r>
                     </a:p>
                   </a:txBody>
@@ -5100,13 +5006,14 @@
                         <a:defRPr/>
                       </a:pPr>
                       <a:r>
-                        <a:rPr lang="en-US" sz="1200" noProof="0">
-                          <a:solidFill>
-                            <a:schemeClr val="tx1"/>
-                          </a:solidFill>
-                        </a:rPr>
-                        <a:t>User database (username:password)</a:t>
+                        <a:rPr lang="en-GB" sz="1200" dirty="0"/>
+                        <a:t>User authentication database</a:t>
                       </a:r>
+                      <a:endParaRPr lang="en-US" sz="1200" noProof="0" dirty="0">
+                        <a:solidFill>
+                          <a:schemeClr val="tx1"/>
+                        </a:solidFill>
+                      </a:endParaRPr>
                     </a:p>
                   </a:txBody>
                   <a:tcPr>
@@ -5162,7 +5069,23 @@
                             <a:schemeClr val="tx1"/>
                           </a:solidFill>
                         </a:rPr>
-                        <a:t>Text file used by Auth Server for authentication</a:t>
+                        <a:t>Text file for authentication (</a:t>
+                      </a:r>
+                      <a:r>
+                        <a:rPr lang="en-US" sz="1200" noProof="0" dirty="0" err="1">
+                          <a:solidFill>
+                            <a:schemeClr val="tx1"/>
+                          </a:solidFill>
+                        </a:rPr>
+                        <a:t>username:hashedpassword:salt:DN</a:t>
+                      </a:r>
+                      <a:r>
+                        <a:rPr lang="en-US" sz="1200" noProof="0" dirty="0">
+                          <a:solidFill>
+                            <a:schemeClr val="tx1"/>
+                          </a:solidFill>
+                        </a:rPr>
+                        <a:t>)</a:t>
                       </a:r>
                     </a:p>
                   </a:txBody>
@@ -5226,7 +5149,7 @@
                             <a:schemeClr val="tx1"/>
                           </a:solidFill>
                         </a:rPr>
-                        <a:t>     user-</a:t>
+                        <a:t>      user-</a:t>
                       </a:r>
                       <a:r>
                         <a:rPr lang="en-US" sz="1200" noProof="0" dirty="0" err="1">
@@ -5410,7 +5333,7 @@
                             <a:schemeClr val="tx1"/>
                           </a:solidFill>
                         </a:rPr>
-                        <a:t>JSON file used by Auth Server for authorization</a:t>
+                        <a:t>JSON file for authorization</a:t>
                       </a:r>
                     </a:p>
                   </a:txBody>
@@ -5474,7 +5397,7 @@
                             <a:schemeClr val="tx1"/>
                           </a:solidFill>
                         </a:rPr>
-                        <a:t>     </a:t>
+                        <a:t>      </a:t>
                       </a:r>
                       <a:r>
                         <a:rPr lang="en-US" sz="1200" noProof="0" dirty="0" err="1">
@@ -5596,13 +5519,14 @@
                     <a:lstStyle/>
                     <a:p>
                       <a:r>
-                        <a:rPr lang="en-US" sz="1200" noProof="0" dirty="0">
-                          <a:solidFill>
-                            <a:schemeClr val="tx1"/>
-                          </a:solidFill>
-                        </a:rPr>
-                        <a:t>Certificate of the UFTPD Server</a:t>
+                        <a:rPr lang="en-GB" sz="1200" dirty="0"/>
+                        <a:t>UFTPD Server certificate</a:t>
                       </a:r>
+                      <a:endParaRPr lang="en-US" sz="1200" noProof="0" dirty="0">
+                        <a:solidFill>
+                          <a:schemeClr val="tx1"/>
+                        </a:solidFill>
+                      </a:endParaRPr>
                     </a:p>
                   </a:txBody>
                   <a:tcPr>
@@ -5653,13 +5577,14 @@
                     <a:lstStyle/>
                     <a:p>
                       <a:r>
-                        <a:rPr lang="en-US" sz="1200" noProof="0" dirty="0">
-                          <a:solidFill>
-                            <a:schemeClr val="tx1"/>
-                          </a:solidFill>
-                        </a:rPr>
-                        <a:t>PEM file with UFTPD cert</a:t>
+                        <a:rPr lang="en-GB" sz="1200" dirty="0"/>
+                        <a:t>PEM file containing the UFTPD server certificate</a:t>
                       </a:r>
+                      <a:endParaRPr lang="en-US" sz="1200" noProof="0" dirty="0">
+                        <a:solidFill>
+                          <a:schemeClr val="tx1"/>
+                        </a:solidFill>
+                      </a:endParaRPr>
                     </a:p>
                   </a:txBody>
                   <a:tcPr>
@@ -5728,7 +5653,7 @@
         </p:nvSpPr>
         <p:spPr>
           <a:xfrm>
-            <a:off x="948543" y="2423558"/>
+            <a:off x="1050153" y="2423558"/>
             <a:ext cx="1584888" cy="307777"/>
           </a:xfrm>
           <a:prstGeom prst="rect">
@@ -5768,7 +5693,7 @@
         </p:nvSpPr>
         <p:spPr>
           <a:xfrm>
-            <a:off x="4706505" y="3494769"/>
+            <a:off x="5105656" y="3569567"/>
             <a:ext cx="1537348" cy="307777"/>
           </a:xfrm>
           <a:prstGeom prst="rect">
@@ -5810,7 +5735,7 @@
         </p:nvSpPr>
         <p:spPr>
           <a:xfrm>
-            <a:off x="9418320" y="2860800"/>
+            <a:off x="9724260" y="2786912"/>
             <a:ext cx="1169632" cy="307777"/>
           </a:xfrm>
           <a:prstGeom prst="rect">
@@ -5860,7 +5785,7 @@
         </p:blipFill>
         <p:spPr>
           <a:xfrm>
-            <a:off x="1182606" y="1433615"/>
+            <a:off x="1284216" y="1433615"/>
             <a:ext cx="981683" cy="725592"/>
           </a:xfrm>
           <a:prstGeom prst="rect">
@@ -5882,7 +5807,7 @@
         </p:nvSpPr>
         <p:spPr>
           <a:xfrm rot="974215">
-            <a:off x="3160498" y="2415987"/>
+            <a:off x="3262108" y="2415987"/>
             <a:ext cx="1439818" cy="261610"/>
           </a:xfrm>
           <a:prstGeom prst="rect">
@@ -5925,8 +5850,8 @@
           <p:nvPr/>
         </p:nvSpPr>
         <p:spPr>
-          <a:xfrm rot="20961920">
-            <a:off x="6979955" y="2480949"/>
+          <a:xfrm rot="20925892">
+            <a:off x="7081565" y="2480949"/>
             <a:ext cx="2291012" cy="261610"/>
           </a:xfrm>
           <a:prstGeom prst="rect">
@@ -5986,7 +5911,7 @@
         </p:nvSpPr>
         <p:spPr>
           <a:xfrm rot="1021969">
-            <a:off x="3479130" y="2138252"/>
+            <a:off x="3580740" y="2110544"/>
             <a:ext cx="1012650" cy="276999"/>
           </a:xfrm>
           <a:prstGeom prst="rect">
@@ -6030,7 +5955,7 @@
         </p:nvSpPr>
         <p:spPr>
           <a:xfrm rot="20919418">
-            <a:off x="7249816" y="2129660"/>
+            <a:off x="7351426" y="2129660"/>
             <a:ext cx="1963596" cy="276999"/>
           </a:xfrm>
           <a:prstGeom prst="rect">
@@ -6045,12 +5970,12 @@
           <a:lstStyle/>
           <a:p>
             <a:r>
-              <a:rPr lang="de-DE" sz="1200" b="1" dirty="0" err="1">
+              <a:rPr lang="en-US" sz="1200" b="1" dirty="0" err="1">
                 <a:solidFill>
                   <a:srgbClr val="4C8C5F"/>
                 </a:solidFill>
               </a:rPr>
-              <a:t>Initiate</a:t>
+              <a:t>Configurire</a:t>
             </a:r>
             <a:r>
               <a:rPr lang="de-DE" sz="1200" b="1" dirty="0">
@@ -6058,31 +5983,7 @@
                   <a:srgbClr val="4C8C5F"/>
                 </a:solidFill>
               </a:rPr>
-              <a:t> </a:t>
-            </a:r>
-            <a:r>
-              <a:rPr lang="de-DE" sz="1200" b="1" dirty="0" err="1">
-                <a:solidFill>
-                  <a:srgbClr val="4C8C5F"/>
-                </a:solidFill>
-              </a:rPr>
-              <a:t>transfer</a:t>
-            </a:r>
-            <a:r>
-              <a:rPr lang="de-DE" sz="1200" b="1" dirty="0">
-                <a:solidFill>
-                  <a:srgbClr val="4C8C5F"/>
-                </a:solidFill>
-              </a:rPr>
-              <a:t> </a:t>
-            </a:r>
-            <a:r>
-              <a:rPr lang="de-DE" sz="1200" b="1" dirty="0" err="1">
-                <a:solidFill>
-                  <a:srgbClr val="4C8C5F"/>
-                </a:solidFill>
-              </a:rPr>
-              <a:t>setup</a:t>
+              <a:t> Transfer Session</a:t>
             </a:r>
             <a:endParaRPr lang="en-GB" sz="1200" b="1" dirty="0">
               <a:solidFill>
@@ -6108,7 +6009,7 @@
         </p:nvCxnSpPr>
         <p:spPr>
           <a:xfrm>
-            <a:off x="2369546" y="1058035"/>
+            <a:off x="2471156" y="1058035"/>
             <a:ext cx="6913364" cy="12002"/>
           </a:xfrm>
           <a:prstGeom prst="line">
@@ -6151,8 +6052,8 @@
         </p:nvSpPr>
         <p:spPr>
           <a:xfrm>
-            <a:off x="5335047" y="772116"/>
-            <a:ext cx="1192121" cy="276999"/>
+            <a:off x="5436657" y="772116"/>
+            <a:ext cx="1716304" cy="276999"/>
           </a:xfrm>
           <a:prstGeom prst="rect">
             <a:avLst/>
@@ -6171,7 +6072,7 @@
                   <a:srgbClr val="285CAA"/>
                 </a:solidFill>
               </a:rPr>
-              <a:t>Login + Transfer</a:t>
+              <a:t>FTP Login + File Transfer</a:t>
             </a:r>
             <a:endParaRPr lang="en-GB" sz="1200" b="1" dirty="0">
               <a:solidFill>
@@ -6195,7 +6096,7 @@
         </p:nvSpPr>
         <p:spPr>
           <a:xfrm>
-            <a:off x="5262069" y="1080154"/>
+            <a:off x="5474511" y="1080154"/>
             <a:ext cx="1369187" cy="261610"/>
           </a:xfrm>
           <a:prstGeom prst="rect">
@@ -6243,7 +6144,7 @@
         </p:nvSpPr>
         <p:spPr>
           <a:xfrm>
-            <a:off x="5045253" y="733383"/>
+            <a:off x="6005844" y="493235"/>
             <a:ext cx="302950" cy="267131"/>
           </a:xfrm>
           <a:prstGeom prst="ellipse">
@@ -6313,7 +6214,7 @@
         </p:blipFill>
         <p:spPr>
           <a:xfrm>
-            <a:off x="1578915" y="5326084"/>
+            <a:off x="962411" y="5191367"/>
             <a:ext cx="190500" cy="219075"/>
           </a:xfrm>
           <a:prstGeom prst="rect">
@@ -6343,7 +6244,7 @@
         </p:blipFill>
         <p:spPr>
           <a:xfrm>
-            <a:off x="1558421" y="5608391"/>
+            <a:off x="945603" y="5437534"/>
             <a:ext cx="238125" cy="228600"/>
           </a:xfrm>
           <a:prstGeom prst="rect">
@@ -6373,7 +6274,7 @@
         </p:blipFill>
         <p:spPr>
           <a:xfrm>
-            <a:off x="1559181" y="5885067"/>
+            <a:off x="944772" y="5711277"/>
             <a:ext cx="200025" cy="228600"/>
           </a:xfrm>
           <a:prstGeom prst="rect">
@@ -6403,7 +6304,7 @@
         </p:blipFill>
         <p:spPr>
           <a:xfrm>
-            <a:off x="1532869" y="6407074"/>
+            <a:off x="954755" y="6267590"/>
             <a:ext cx="247650" cy="257175"/>
           </a:xfrm>
           <a:prstGeom prst="rect">
@@ -6433,7 +6334,7 @@
         </p:blipFill>
         <p:spPr>
           <a:xfrm>
-            <a:off x="1559181" y="6158369"/>
+            <a:off x="969415" y="6005983"/>
             <a:ext cx="190500" cy="219075"/>
           </a:xfrm>
           <a:prstGeom prst="rect">
@@ -6463,7 +6364,7 @@
         </p:blipFill>
         <p:spPr>
           <a:xfrm>
-            <a:off x="5260452" y="2298601"/>
+            <a:off x="5362062" y="2418669"/>
             <a:ext cx="1047605" cy="1047605"/>
           </a:xfrm>
           <a:prstGeom prst="rect">
@@ -6493,7 +6394,7 @@
         </p:blipFill>
         <p:spPr>
           <a:xfrm>
-            <a:off x="9650613" y="1512823"/>
+            <a:off x="9752223" y="1512823"/>
             <a:ext cx="1047605" cy="1047605"/>
           </a:xfrm>
           <a:prstGeom prst="rect">
@@ -6515,7 +6416,7 @@
         </p:nvSpPr>
         <p:spPr>
           <a:xfrm rot="20794480">
-            <a:off x="6930077" y="2320970"/>
+            <a:off x="7909136" y="1896101"/>
             <a:ext cx="302950" cy="267131"/>
           </a:xfrm>
           <a:prstGeom prst="ellipse">
@@ -6577,7 +6478,7 @@
         </p:nvSpPr>
         <p:spPr>
           <a:xfrm rot="1114517">
-            <a:off x="3239923" y="1928495"/>
+            <a:off x="4061966" y="1854607"/>
             <a:ext cx="302950" cy="267131"/>
           </a:xfrm>
           <a:prstGeom prst="ellipse">
@@ -6622,6 +6523,70 @@
                 <a:schemeClr val="tx2"/>
               </a:solidFill>
             </a:endParaRPr>
+          </a:p>
+        </p:txBody>
+      </p:sp>
+      <p:sp>
+        <p:nvSpPr>
+          <p:cNvPr id="189" name="Textfeld 188">
+            <a:extLst>
+              <a:ext uri="{FF2B5EF4-FFF2-40B4-BE49-F238E27FC236}">
+                <a16:creationId xmlns:a16="http://schemas.microsoft.com/office/drawing/2014/main" id="{65812381-66C4-429C-BA24-FA3C0EDC564E}"/>
+              </a:ext>
+            </a:extLst>
+          </p:cNvPr>
+          <p:cNvSpPr txBox="1"/>
+          <p:nvPr/>
+        </p:nvSpPr>
+        <p:spPr>
+          <a:xfrm>
+            <a:off x="5734997" y="3860576"/>
+            <a:ext cx="1562965" cy="461665"/>
+          </a:xfrm>
+          <a:prstGeom prst="rect">
+            <a:avLst/>
+          </a:prstGeom>
+          <a:noFill/>
+        </p:spPr>
+        <p:txBody>
+          <a:bodyPr wrap="square">
+            <a:spAutoFit/>
+          </a:bodyPr>
+          <a:lstStyle/>
+          <a:p>
+            <a:pPr>
+              <a:defRPr sz="1400"/>
+            </a:pPr>
+            <a:r>
+              <a:rPr lang="en-GB" sz="1200" dirty="0">
+                <a:solidFill>
+                  <a:srgbClr val="002060"/>
+                </a:solidFill>
+              </a:rPr>
+              <a:t>• user-authfile.txt</a:t>
+            </a:r>
+          </a:p>
+          <a:p>
+            <a:pPr>
+              <a:defRPr sz="1400"/>
+            </a:pPr>
+            <a:r>
+              <a:rPr lang="en-GB" sz="1200" dirty="0">
+                <a:solidFill>
+                  <a:srgbClr val="002060"/>
+                </a:solidFill>
+              </a:rPr>
+              <a:t>• user-</a:t>
+            </a:r>
+            <a:r>
+              <a:rPr lang="en-GB" sz="1200" dirty="0" err="1">
+                <a:solidFill>
+                  <a:srgbClr val="002060"/>
+                </a:solidFill>
+              </a:rPr>
+              <a:t>mapfile.json</a:t>
+            </a:r>
+            <a:endParaRPr lang="en-GB" sz="1200" dirty="0"/>
           </a:p>
         </p:txBody>
       </p:sp>

</xml_diff>

<commit_message>
update test installation figure
</commit_message>
<xml_diff>
--- a/source/_static/test-uftp-setup.pptx
+++ b/source/_static/test-uftp-setup.pptx
@@ -4092,9 +4092,7 @@
           </a:prstGeom>
           <a:ln>
             <a:solidFill>
-              <a:schemeClr val="accent3">
-                <a:lumMod val="75000"/>
-              </a:schemeClr>
+              <a:srgbClr val="4C8C5F"/>
             </a:solidFill>
             <a:headEnd type="diamond"/>
             <a:tailEnd type="triangle"/>
@@ -5806,8 +5804,8 @@
           <p:nvPr/>
         </p:nvSpPr>
         <p:spPr>
-          <a:xfrm rot="974215">
-            <a:off x="3262108" y="2415987"/>
+          <a:xfrm rot="1011934">
+            <a:off x="3142040" y="2637651"/>
             <a:ext cx="1439818" cy="261610"/>
           </a:xfrm>
           <a:prstGeom prst="rect">
@@ -5850,8 +5848,8 @@
           <p:nvPr/>
         </p:nvSpPr>
         <p:spPr>
-          <a:xfrm rot="20925892">
-            <a:off x="7081565" y="2480949"/>
+          <a:xfrm rot="20905888">
+            <a:off x="7026149" y="2758031"/>
             <a:ext cx="2291012" cy="261610"/>
           </a:xfrm>
           <a:prstGeom prst="rect">
@@ -5911,7 +5909,7 @@
         </p:nvSpPr>
         <p:spPr>
           <a:xfrm rot="1021969">
-            <a:off x="3580740" y="2110544"/>
+            <a:off x="3423728" y="2415339"/>
             <a:ext cx="1012650" cy="276999"/>
           </a:xfrm>
           <a:prstGeom prst="rect">
@@ -5955,7 +5953,7 @@
         </p:nvSpPr>
         <p:spPr>
           <a:xfrm rot="20919418">
-            <a:off x="7351426" y="2129660"/>
+            <a:off x="7129754" y="2536055"/>
             <a:ext cx="1963596" cy="276999"/>
           </a:xfrm>
           <a:prstGeom prst="rect">
@@ -5970,12 +5968,12 @@
           <a:lstStyle/>
           <a:p>
             <a:r>
-              <a:rPr lang="en-US" sz="1200" b="1" dirty="0" err="1">
+              <a:rPr lang="en-US" sz="1200" b="1" dirty="0">
                 <a:solidFill>
                   <a:srgbClr val="4C8C5F"/>
                 </a:solidFill>
               </a:rPr>
-              <a:t>Configurire</a:t>
+              <a:t>Configure</a:t>
             </a:r>
             <a:r>
               <a:rPr lang="de-DE" sz="1200" b="1" dirty="0">
@@ -6052,7 +6050,7 @@
         </p:nvSpPr>
         <p:spPr>
           <a:xfrm>
-            <a:off x="5436657" y="772116"/>
+            <a:off x="5335061" y="1123090"/>
             <a:ext cx="1716304" cy="276999"/>
           </a:xfrm>
           <a:prstGeom prst="rect">
@@ -6096,7 +6094,7 @@
         </p:nvSpPr>
         <p:spPr>
           <a:xfrm>
-            <a:off x="5474511" y="1080154"/>
+            <a:off x="5474511" y="1348002"/>
             <a:ext cx="1369187" cy="261610"/>
           </a:xfrm>
           <a:prstGeom prst="rect">
@@ -6144,7 +6142,7 @@
         </p:nvSpPr>
         <p:spPr>
           <a:xfrm>
-            <a:off x="6005844" y="493235"/>
+            <a:off x="5950428" y="696427"/>
             <a:ext cx="302950" cy="267131"/>
           </a:xfrm>
           <a:prstGeom prst="ellipse">
@@ -6177,14 +6175,14 @@
           <a:p>
             <a:pPr algn="ctr"/>
             <a:r>
-              <a:rPr lang="de-DE" sz="1200" dirty="0">
+              <a:rPr lang="de-DE" sz="1200" b="1" dirty="0">
                 <a:solidFill>
                   <a:schemeClr val="tx2"/>
                 </a:solidFill>
               </a:rPr>
               <a:t>3</a:t>
             </a:r>
-            <a:endParaRPr lang="en-GB" sz="1200" dirty="0">
+            <a:endParaRPr lang="en-GB" sz="1200" b="1" dirty="0">
               <a:solidFill>
                 <a:schemeClr val="tx2"/>
               </a:solidFill>
@@ -6416,7 +6414,7 @@
         </p:nvSpPr>
         <p:spPr>
           <a:xfrm rot="20794480">
-            <a:off x="7909136" y="1896101"/>
+            <a:off x="7816776" y="2136239"/>
             <a:ext cx="302950" cy="267131"/>
           </a:xfrm>
           <a:prstGeom prst="ellipse">
@@ -6449,14 +6447,14 @@
           <a:p>
             <a:pPr algn="ctr"/>
             <a:r>
-              <a:rPr lang="de-DE" sz="1200" dirty="0">
+              <a:rPr lang="de-DE" sz="1200" b="1" dirty="0">
                 <a:solidFill>
                   <a:srgbClr val="4C8C5F"/>
                 </a:solidFill>
               </a:rPr>
               <a:t>2</a:t>
             </a:r>
-            <a:endParaRPr lang="en-GB" sz="1200" dirty="0">
+            <a:endParaRPr lang="en-GB" sz="1200" b="1" dirty="0">
               <a:solidFill>
                 <a:srgbClr val="4C8C5F"/>
               </a:solidFill>
@@ -6478,7 +6476,7 @@
         </p:nvSpPr>
         <p:spPr>
           <a:xfrm rot="1114517">
-            <a:off x="4061966" y="1854607"/>
+            <a:off x="3877239" y="2002387"/>
             <a:ext cx="302950" cy="267131"/>
           </a:xfrm>
           <a:prstGeom prst="ellipse">
@@ -6511,14 +6509,14 @@
           <a:p>
             <a:pPr algn="ctr"/>
             <a:r>
-              <a:rPr lang="de-DE" sz="1200" dirty="0">
+              <a:rPr lang="de-DE" sz="1200" b="1" dirty="0">
                 <a:solidFill>
                   <a:schemeClr val="tx2"/>
                 </a:solidFill>
               </a:rPr>
               <a:t>1</a:t>
             </a:r>
-            <a:endParaRPr lang="en-GB" sz="1200" dirty="0">
+            <a:endParaRPr lang="en-GB" sz="1200" b="1" dirty="0">
               <a:solidFill>
                 <a:schemeClr val="tx2"/>
               </a:solidFill>

</xml_diff>